<commit_message>
Added SeatLayout and Theme Toggle
</commit_message>
<xml_diff>
--- a/project-snapshots/ppt/seat-mgmt-system.pptx
+++ b/project-snapshots/ppt/seat-mgmt-system.pptx
@@ -5,18 +5,21 @@
     <p:sldMasterId id="2147483658" r:id="rId4"/>
   </p:sldMasterIdLst>
   <p:notesMasterIdLst>
-    <p:notesMasterId r:id="rId11"/>
+    <p:notesMasterId r:id="rId14"/>
   </p:notesMasterIdLst>
   <p:handoutMasterIdLst>
-    <p:handoutMasterId r:id="rId12"/>
+    <p:handoutMasterId r:id="rId15"/>
   </p:handoutMasterIdLst>
   <p:sldIdLst>
     <p:sldId id="410" r:id="rId5"/>
     <p:sldId id="383" r:id="rId6"/>
     <p:sldId id="391" r:id="rId7"/>
     <p:sldId id="408" r:id="rId8"/>
-    <p:sldId id="411" r:id="rId9"/>
-    <p:sldId id="398" r:id="rId10"/>
+    <p:sldId id="414" r:id="rId9"/>
+    <p:sldId id="413" r:id="rId10"/>
+    <p:sldId id="411" r:id="rId11"/>
+    <p:sldId id="412" r:id="rId12"/>
+    <p:sldId id="398" r:id="rId13"/>
   </p:sldIdLst>
   <p:sldSz cx="12192000" cy="6858000"/>
   <p:notesSz cx="6858000" cy="9144000"/>
@@ -1020,6 +1023,222 @@
         <p:cNvPr id="1" name="">
           <a:extLst>
             <a:ext uri="{FF2B5EF4-FFF2-40B4-BE49-F238E27FC236}">
+              <a16:creationId xmlns:a16="http://schemas.microsoft.com/office/drawing/2014/main" id="{98B8C822-F857-FEDA-7646-C89102D7B4F4}"/>
+            </a:ext>
+          </a:extLst>
+        </p:cNvPr>
+        <p:cNvGrpSpPr/>
+        <p:nvPr/>
+      </p:nvGrpSpPr>
+      <p:grpSpPr>
+        <a:xfrm>
+          <a:off x="0" y="0"/>
+          <a:ext cx="0" cy="0"/>
+          <a:chOff x="0" y="0"/>
+          <a:chExt cx="0" cy="0"/>
+        </a:xfrm>
+      </p:grpSpPr>
+      <p:sp>
+        <p:nvSpPr>
+          <p:cNvPr id="2" name="Slide Image Placeholder 1">
+            <a:extLst>
+              <a:ext uri="{FF2B5EF4-FFF2-40B4-BE49-F238E27FC236}">
+                <a16:creationId xmlns:a16="http://schemas.microsoft.com/office/drawing/2014/main" id="{6B5BB8E1-990E-D907-3374-1F0DF635E37F}"/>
+              </a:ext>
+            </a:extLst>
+          </p:cNvPr>
+          <p:cNvSpPr>
+            <a:spLocks noGrp="1" noRot="1" noChangeAspect="1"/>
+          </p:cNvSpPr>
+          <p:nvPr>
+            <p:ph type="sldImg"/>
+          </p:nvPr>
+        </p:nvSpPr>
+        <p:spPr/>
+      </p:sp>
+      <p:sp>
+        <p:nvSpPr>
+          <p:cNvPr id="3" name="Notes Placeholder 2">
+            <a:extLst>
+              <a:ext uri="{FF2B5EF4-FFF2-40B4-BE49-F238E27FC236}">
+                <a16:creationId xmlns:a16="http://schemas.microsoft.com/office/drawing/2014/main" id="{0EFC8855-3FCC-EB88-08E6-968C23AF37C9}"/>
+              </a:ext>
+            </a:extLst>
+          </p:cNvPr>
+          <p:cNvSpPr>
+            <a:spLocks noGrp="1"/>
+          </p:cNvSpPr>
+          <p:nvPr>
+            <p:ph type="body" idx="1"/>
+          </p:nvPr>
+        </p:nvSpPr>
+        <p:spPr/>
+        <p:txBody>
+          <a:bodyPr/>
+          <a:lstStyle/>
+          <a:p>
+            <a:endParaRPr lang="en-US" dirty="0"/>
+          </a:p>
+        </p:txBody>
+      </p:sp>
+      <p:sp>
+        <p:nvSpPr>
+          <p:cNvPr id="4" name="Slide Number Placeholder 3">
+            <a:extLst>
+              <a:ext uri="{FF2B5EF4-FFF2-40B4-BE49-F238E27FC236}">
+                <a16:creationId xmlns:a16="http://schemas.microsoft.com/office/drawing/2014/main" id="{F6DE4A54-8D81-2CD5-CF67-9F8E57CF20A6}"/>
+              </a:ext>
+            </a:extLst>
+          </p:cNvPr>
+          <p:cNvSpPr>
+            <a:spLocks noGrp="1"/>
+          </p:cNvSpPr>
+          <p:nvPr>
+            <p:ph type="sldNum" sz="quarter" idx="5"/>
+          </p:nvPr>
+        </p:nvSpPr>
+        <p:spPr/>
+        <p:txBody>
+          <a:bodyPr/>
+          <a:lstStyle/>
+          <a:p>
+            <a:fld id="{A89C7E07-3C67-C64C-8DA0-0404F6303970}" type="slidenum">
+              <a:rPr lang="en-US" smtClean="0"/>
+              <a:t>5</a:t>
+            </a:fld>
+            <a:endParaRPr lang="en-US" dirty="0"/>
+          </a:p>
+        </p:txBody>
+      </p:sp>
+    </p:spTree>
+    <p:extLst>
+      <p:ext uri="{BB962C8B-B14F-4D97-AF65-F5344CB8AC3E}">
+        <p14:creationId xmlns:p14="http://schemas.microsoft.com/office/powerpoint/2010/main" val="3606217609"/>
+      </p:ext>
+    </p:extLst>
+  </p:cSld>
+  <p:clrMapOvr>
+    <a:masterClrMapping/>
+  </p:clrMapOvr>
+</p:notes>
+</file>
+
+<file path=ppt/notesSlides/notesSlide6.xml><?xml version="1.0" encoding="utf-8"?>
+<p:notes xmlns:a="http://schemas.openxmlformats.org/drawingml/2006/main" xmlns:r="http://schemas.openxmlformats.org/officeDocument/2006/relationships" xmlns:p="http://schemas.openxmlformats.org/presentationml/2006/main">
+  <p:cSld>
+    <p:spTree>
+      <p:nvGrpSpPr>
+        <p:cNvPr id="1" name="">
+          <a:extLst>
+            <a:ext uri="{FF2B5EF4-FFF2-40B4-BE49-F238E27FC236}">
+              <a16:creationId xmlns:a16="http://schemas.microsoft.com/office/drawing/2014/main" id="{63B21808-48B5-5CAA-A7DC-7039B37D022B}"/>
+            </a:ext>
+          </a:extLst>
+        </p:cNvPr>
+        <p:cNvGrpSpPr/>
+        <p:nvPr/>
+      </p:nvGrpSpPr>
+      <p:grpSpPr>
+        <a:xfrm>
+          <a:off x="0" y="0"/>
+          <a:ext cx="0" cy="0"/>
+          <a:chOff x="0" y="0"/>
+          <a:chExt cx="0" cy="0"/>
+        </a:xfrm>
+      </p:grpSpPr>
+      <p:sp>
+        <p:nvSpPr>
+          <p:cNvPr id="2" name="Slide Image Placeholder 1">
+            <a:extLst>
+              <a:ext uri="{FF2B5EF4-FFF2-40B4-BE49-F238E27FC236}">
+                <a16:creationId xmlns:a16="http://schemas.microsoft.com/office/drawing/2014/main" id="{79DCF604-E2A5-1798-F902-DE800BDF1766}"/>
+              </a:ext>
+            </a:extLst>
+          </p:cNvPr>
+          <p:cNvSpPr>
+            <a:spLocks noGrp="1" noRot="1" noChangeAspect="1"/>
+          </p:cNvSpPr>
+          <p:nvPr>
+            <p:ph type="sldImg"/>
+          </p:nvPr>
+        </p:nvSpPr>
+        <p:spPr/>
+      </p:sp>
+      <p:sp>
+        <p:nvSpPr>
+          <p:cNvPr id="3" name="Notes Placeholder 2">
+            <a:extLst>
+              <a:ext uri="{FF2B5EF4-FFF2-40B4-BE49-F238E27FC236}">
+                <a16:creationId xmlns:a16="http://schemas.microsoft.com/office/drawing/2014/main" id="{1F8F17F4-B90A-9889-5EF1-089FF0C10FB2}"/>
+              </a:ext>
+            </a:extLst>
+          </p:cNvPr>
+          <p:cNvSpPr>
+            <a:spLocks noGrp="1"/>
+          </p:cNvSpPr>
+          <p:nvPr>
+            <p:ph type="body" idx="1"/>
+          </p:nvPr>
+        </p:nvSpPr>
+        <p:spPr/>
+        <p:txBody>
+          <a:bodyPr/>
+          <a:lstStyle/>
+          <a:p>
+            <a:endParaRPr lang="en-US" dirty="0"/>
+          </a:p>
+        </p:txBody>
+      </p:sp>
+      <p:sp>
+        <p:nvSpPr>
+          <p:cNvPr id="4" name="Slide Number Placeholder 3">
+            <a:extLst>
+              <a:ext uri="{FF2B5EF4-FFF2-40B4-BE49-F238E27FC236}">
+                <a16:creationId xmlns:a16="http://schemas.microsoft.com/office/drawing/2014/main" id="{7F207A27-5D7A-397C-A614-F3490FC35701}"/>
+              </a:ext>
+            </a:extLst>
+          </p:cNvPr>
+          <p:cNvSpPr>
+            <a:spLocks noGrp="1"/>
+          </p:cNvSpPr>
+          <p:nvPr>
+            <p:ph type="sldNum" sz="quarter" idx="5"/>
+          </p:nvPr>
+        </p:nvSpPr>
+        <p:spPr/>
+        <p:txBody>
+          <a:bodyPr/>
+          <a:lstStyle/>
+          <a:p>
+            <a:fld id="{A89C7E07-3C67-C64C-8DA0-0404F6303970}" type="slidenum">
+              <a:rPr lang="en-US" smtClean="0"/>
+              <a:t>6</a:t>
+            </a:fld>
+            <a:endParaRPr lang="en-US" dirty="0"/>
+          </a:p>
+        </p:txBody>
+      </p:sp>
+    </p:spTree>
+    <p:extLst>
+      <p:ext uri="{BB962C8B-B14F-4D97-AF65-F5344CB8AC3E}">
+        <p14:creationId xmlns:p14="http://schemas.microsoft.com/office/powerpoint/2010/main" val="4047897277"/>
+      </p:ext>
+    </p:extLst>
+  </p:cSld>
+  <p:clrMapOvr>
+    <a:masterClrMapping/>
+  </p:clrMapOvr>
+</p:notes>
+</file>
+
+<file path=ppt/notesSlides/notesSlide7.xml><?xml version="1.0" encoding="utf-8"?>
+<p:notes xmlns:a="http://schemas.openxmlformats.org/drawingml/2006/main" xmlns:r="http://schemas.openxmlformats.org/officeDocument/2006/relationships" xmlns:p="http://schemas.openxmlformats.org/presentationml/2006/main">
+  <p:cSld>
+    <p:spTree>
+      <p:nvGrpSpPr>
+        <p:cNvPr id="1" name="">
+          <a:extLst>
+            <a:ext uri="{FF2B5EF4-FFF2-40B4-BE49-F238E27FC236}">
               <a16:creationId xmlns:a16="http://schemas.microsoft.com/office/drawing/2014/main" id="{C6D30691-0275-C1D7-5DD5-7611DA07D01F}"/>
             </a:ext>
           </a:extLst>
@@ -1101,7 +1320,7 @@
           <a:p>
             <a:fld id="{A89C7E07-3C67-C64C-8DA0-0404F6303970}" type="slidenum">
               <a:rPr lang="en-US" smtClean="0"/>
-              <a:t>5</a:t>
+              <a:t>7</a:t>
             </a:fld>
             <a:endParaRPr lang="en-US" dirty="0"/>
           </a:p>
@@ -1120,7 +1339,115 @@
 </p:notes>
 </file>
 
-<file path=ppt/notesSlides/notesSlide6.xml><?xml version="1.0" encoding="utf-8"?>
+<file path=ppt/notesSlides/notesSlide8.xml><?xml version="1.0" encoding="utf-8"?>
+<p:notes xmlns:a="http://schemas.openxmlformats.org/drawingml/2006/main" xmlns:r="http://schemas.openxmlformats.org/officeDocument/2006/relationships" xmlns:p="http://schemas.openxmlformats.org/presentationml/2006/main">
+  <p:cSld>
+    <p:spTree>
+      <p:nvGrpSpPr>
+        <p:cNvPr id="1" name="">
+          <a:extLst>
+            <a:ext uri="{FF2B5EF4-FFF2-40B4-BE49-F238E27FC236}">
+              <a16:creationId xmlns:a16="http://schemas.microsoft.com/office/drawing/2014/main" id="{6FABBF0D-ABA8-6851-FD74-C3EEA1A3CB07}"/>
+            </a:ext>
+          </a:extLst>
+        </p:cNvPr>
+        <p:cNvGrpSpPr/>
+        <p:nvPr/>
+      </p:nvGrpSpPr>
+      <p:grpSpPr>
+        <a:xfrm>
+          <a:off x="0" y="0"/>
+          <a:ext cx="0" cy="0"/>
+          <a:chOff x="0" y="0"/>
+          <a:chExt cx="0" cy="0"/>
+        </a:xfrm>
+      </p:grpSpPr>
+      <p:sp>
+        <p:nvSpPr>
+          <p:cNvPr id="2" name="Slide Image Placeholder 1">
+            <a:extLst>
+              <a:ext uri="{FF2B5EF4-FFF2-40B4-BE49-F238E27FC236}">
+                <a16:creationId xmlns:a16="http://schemas.microsoft.com/office/drawing/2014/main" id="{7E6620F6-24A5-3E46-D4BA-C88CC1EC946B}"/>
+              </a:ext>
+            </a:extLst>
+          </p:cNvPr>
+          <p:cNvSpPr>
+            <a:spLocks noGrp="1" noRot="1" noChangeAspect="1"/>
+          </p:cNvSpPr>
+          <p:nvPr>
+            <p:ph type="sldImg"/>
+          </p:nvPr>
+        </p:nvSpPr>
+        <p:spPr/>
+      </p:sp>
+      <p:sp>
+        <p:nvSpPr>
+          <p:cNvPr id="3" name="Notes Placeholder 2">
+            <a:extLst>
+              <a:ext uri="{FF2B5EF4-FFF2-40B4-BE49-F238E27FC236}">
+                <a16:creationId xmlns:a16="http://schemas.microsoft.com/office/drawing/2014/main" id="{45CF5904-E13B-F7D8-4BE5-E31523F9D715}"/>
+              </a:ext>
+            </a:extLst>
+          </p:cNvPr>
+          <p:cNvSpPr>
+            <a:spLocks noGrp="1"/>
+          </p:cNvSpPr>
+          <p:nvPr>
+            <p:ph type="body" idx="1"/>
+          </p:nvPr>
+        </p:nvSpPr>
+        <p:spPr/>
+        <p:txBody>
+          <a:bodyPr/>
+          <a:lstStyle/>
+          <a:p>
+            <a:endParaRPr lang="en-US" dirty="0"/>
+          </a:p>
+        </p:txBody>
+      </p:sp>
+      <p:sp>
+        <p:nvSpPr>
+          <p:cNvPr id="4" name="Slide Number Placeholder 3">
+            <a:extLst>
+              <a:ext uri="{FF2B5EF4-FFF2-40B4-BE49-F238E27FC236}">
+                <a16:creationId xmlns:a16="http://schemas.microsoft.com/office/drawing/2014/main" id="{E33B3923-F3FB-A922-F699-02EC0E83B489}"/>
+              </a:ext>
+            </a:extLst>
+          </p:cNvPr>
+          <p:cNvSpPr>
+            <a:spLocks noGrp="1"/>
+          </p:cNvSpPr>
+          <p:nvPr>
+            <p:ph type="sldNum" sz="quarter" idx="5"/>
+          </p:nvPr>
+        </p:nvSpPr>
+        <p:spPr/>
+        <p:txBody>
+          <a:bodyPr/>
+          <a:lstStyle/>
+          <a:p>
+            <a:fld id="{A89C7E07-3C67-C64C-8DA0-0404F6303970}" type="slidenum">
+              <a:rPr lang="en-US" smtClean="0"/>
+              <a:t>8</a:t>
+            </a:fld>
+            <a:endParaRPr lang="en-US" dirty="0"/>
+          </a:p>
+        </p:txBody>
+      </p:sp>
+    </p:spTree>
+    <p:extLst>
+      <p:ext uri="{BB962C8B-B14F-4D97-AF65-F5344CB8AC3E}">
+        <p14:creationId xmlns:p14="http://schemas.microsoft.com/office/powerpoint/2010/main" val="313939721"/>
+      </p:ext>
+    </p:extLst>
+  </p:cSld>
+  <p:clrMapOvr>
+    <a:masterClrMapping/>
+  </p:clrMapOvr>
+</p:notes>
+</file>
+
+<file path=ppt/notesSlides/notesSlide9.xml><?xml version="1.0" encoding="utf-8"?>
 <p:notes xmlns:a="http://schemas.openxmlformats.org/drawingml/2006/main" xmlns:r="http://schemas.openxmlformats.org/officeDocument/2006/relationships" xmlns:p="http://schemas.openxmlformats.org/presentationml/2006/main">
   <p:cSld>
     <p:spTree>
@@ -1185,7 +1512,7 @@
           <a:p>
             <a:fld id="{A89C7E07-3C67-C64C-8DA0-0404F6303970}" type="slidenum">
               <a:rPr lang="en-US" smtClean="0"/>
-              <a:t>6</a:t>
+              <a:t>9</a:t>
             </a:fld>
             <a:endParaRPr lang="en-US" dirty="0"/>
           </a:p>
@@ -9584,7 +9911,7 @@
         <p:spPr>
           <a:xfrm>
             <a:off x="7426519" y="4158532"/>
-            <a:ext cx="3212327" cy="369332"/>
+            <a:ext cx="3212327" cy="646331"/>
           </a:xfrm>
           <a:prstGeom prst="rect">
             <a:avLst/>
@@ -9597,19 +9924,40 @@
           </a:bodyPr>
           <a:lstStyle/>
           <a:p>
-            <a:endParaRPr lang="en-US" b="1" dirty="0">
-              <a:solidFill>
-                <a:schemeClr val="bg1"/>
-              </a:solidFill>
-              <a:effectLst>
-                <a:outerShdw blurRad="38100" dist="38100" dir="2700000" algn="tl">
-                  <a:srgbClr val="000000">
-                    <a:alpha val="43137"/>
-                  </a:srgbClr>
-                </a:outerShdw>
-              </a:effectLst>
-              <a:latin typeface="Arial Narrow" panose="020B0606020202030204" pitchFamily="34" charset="0"/>
-            </a:endParaRPr>
+            <a:r>
+              <a:rPr lang="en-US" b="1" dirty="0">
+                <a:solidFill>
+                  <a:schemeClr val="bg1"/>
+                </a:solidFill>
+                <a:effectLst>
+                  <a:outerShdw blurRad="38100" dist="38100" dir="2700000" algn="tl">
+                    <a:srgbClr val="000000">
+                      <a:alpha val="43137"/>
+                    </a:srgbClr>
+                  </a:outerShdw>
+                </a:effectLst>
+                <a:latin typeface="Arial Narrow" panose="020B0606020202030204" pitchFamily="34" charset="0"/>
+              </a:rPr>
+              <a:t>By</a:t>
+            </a:r>
+          </a:p>
+          <a:p>
+            <a:r>
+              <a:rPr lang="en-US" b="1" dirty="0">
+                <a:solidFill>
+                  <a:schemeClr val="bg1"/>
+                </a:solidFill>
+                <a:effectLst>
+                  <a:outerShdw blurRad="38100" dist="38100" dir="2700000" algn="tl">
+                    <a:srgbClr val="000000">
+                      <a:alpha val="43137"/>
+                    </a:srgbClr>
+                  </a:outerShdw>
+                </a:effectLst>
+                <a:latin typeface="Arial Narrow" panose="020B0606020202030204" pitchFamily="34" charset="0"/>
+              </a:rPr>
+              <a:t>Suricha Sinha</a:t>
+            </a:r>
           </a:p>
         </p:txBody>
       </p:sp>
@@ -9694,80 +10042,23 @@
         </p:nvSpPr>
         <p:spPr>
           <a:xfrm>
-            <a:off x="1404758" y="2376654"/>
-            <a:ext cx="3358073" cy="3709987"/>
+            <a:off x="5068970" y="2885537"/>
+            <a:ext cx="4528254" cy="3709987"/>
           </a:xfrm>
         </p:spPr>
         <p:txBody>
           <a:bodyPr tIns="457200">
-            <a:normAutofit lnSpcReduction="10000"/>
+            <a:normAutofit/>
           </a:bodyPr>
           <a:lstStyle/>
-          <a:p>
-            <a:r>
-              <a:rPr lang="en-US" dirty="0"/>
-              <a:t>Frontend</a:t>
-            </a:r>
-          </a:p>
-          <a:p>
-            <a:pPr lvl="1"/>
-            <a:r>
-              <a:rPr lang="en-US" dirty="0"/>
-              <a:t>React.js</a:t>
-            </a:r>
-          </a:p>
-          <a:p>
-            <a:pPr lvl="1"/>
-            <a:r>
-              <a:rPr lang="en-US" dirty="0"/>
-              <a:t>Tailwind CSS</a:t>
-            </a:r>
-          </a:p>
-          <a:p>
-            <a:pPr lvl="1"/>
-            <a:r>
-              <a:rPr lang="en-US" dirty="0"/>
-              <a:t>Axios</a:t>
-            </a:r>
-          </a:p>
-          <a:p>
-            <a:pPr marL="402336" lvl="1" indent="0">
-              <a:buNone/>
-            </a:pPr>
-            <a:endParaRPr lang="en-US" dirty="0"/>
-          </a:p>
-          <a:p>
-            <a:r>
-              <a:rPr lang="en-US" dirty="0"/>
-              <a:t>Backend</a:t>
-            </a:r>
-          </a:p>
-          <a:p>
-            <a:pPr lvl="1"/>
-            <a:r>
-              <a:rPr lang="en-US" dirty="0"/>
-              <a:t>Node.js</a:t>
-            </a:r>
-          </a:p>
-          <a:p>
-            <a:pPr lvl="1"/>
-            <a:r>
-              <a:rPr lang="en-US" dirty="0"/>
-              <a:t>Express</a:t>
-            </a:r>
-          </a:p>
-          <a:p>
-            <a:pPr lvl="1"/>
-            <a:r>
-              <a:rPr lang="en-US" dirty="0"/>
-              <a:t>JWT Authentication</a:t>
-            </a:r>
-          </a:p>
           <a:p>
             <a:pPr marL="0" indent="0">
               <a:buNone/>
             </a:pPr>
-            <a:endParaRPr lang="en-US" dirty="0"/>
+            <a:r>
+              <a:rPr lang="en-US" dirty="0"/>
+              <a:t>A deterministic, policy-enforced seat allocation engine that combines algorithm-driven batch rotation with dynamic seat reallocation to optimize hybrid workforce utilization at scale.</a:t>
+            </a:r>
           </a:p>
         </p:txBody>
       </p:sp>
@@ -9965,6 +10256,372 @@
             </a:lvl9pPr>
           </a:lstStyle>
           <a:p>
+            <a:pPr marL="0" indent="0">
+              <a:buFont typeface="Arial" panose="020B0604020202020204" pitchFamily="34" charset="0"/>
+              <a:buNone/>
+            </a:pPr>
+            <a:endParaRPr lang="en-US" dirty="0"/>
+          </a:p>
+        </p:txBody>
+      </p:sp>
+      <p:sp>
+        <p:nvSpPr>
+          <p:cNvPr id="7" name="Title 1">
+            <a:extLst>
+              <a:ext uri="{FF2B5EF4-FFF2-40B4-BE49-F238E27FC236}">
+                <a16:creationId xmlns:a16="http://schemas.microsoft.com/office/drawing/2014/main" id="{FFD168C6-8C7C-F5BA-959E-9CDACDD7F4B3}"/>
+              </a:ext>
+            </a:extLst>
+          </p:cNvPr>
+          <p:cNvSpPr txBox="1">
+            <a:spLocks/>
+          </p:cNvSpPr>
+          <p:nvPr/>
+        </p:nvSpPr>
+        <p:spPr>
+          <a:xfrm>
+            <a:off x="6358731" y="1407743"/>
+            <a:ext cx="1948732" cy="1593507"/>
+          </a:xfrm>
+          <a:prstGeom prst="rect">
+            <a:avLst/>
+          </a:prstGeom>
+        </p:spPr>
+        <p:txBody>
+          <a:bodyPr vert="horz" lIns="0" tIns="0" rIns="0" bIns="0" rtlCol="0" anchor="b" anchorCtr="0">
+            <a:noAutofit/>
+          </a:bodyPr>
+          <a:lstStyle>
+            <a:lvl1pPr algn="l" defTabSz="914400" rtl="0" eaLnBrk="1" latinLnBrk="0" hangingPunct="1">
+              <a:lnSpc>
+                <a:spcPct val="80000"/>
+              </a:lnSpc>
+              <a:spcBef>
+                <a:spcPct val="0"/>
+              </a:spcBef>
+              <a:buNone/>
+              <a:defRPr sz="4400" b="1" i="0" kern="1200" spc="50" baseline="0">
+                <a:solidFill>
+                  <a:schemeClr val="bg1"/>
+                </a:solidFill>
+                <a:latin typeface="+mj-lt"/>
+                <a:ea typeface="+mj-ea"/>
+                <a:cs typeface="+mj-cs"/>
+              </a:defRPr>
+            </a:lvl1pPr>
+            <a:lvl2pPr eaLnBrk="1" hangingPunct="1">
+              <a:defRPr>
+                <a:solidFill>
+                  <a:schemeClr val="tx2"/>
+                </a:solidFill>
+              </a:defRPr>
+            </a:lvl2pPr>
+            <a:lvl3pPr eaLnBrk="1" hangingPunct="1">
+              <a:defRPr>
+                <a:solidFill>
+                  <a:schemeClr val="tx2"/>
+                </a:solidFill>
+              </a:defRPr>
+            </a:lvl3pPr>
+            <a:lvl4pPr eaLnBrk="1" hangingPunct="1">
+              <a:defRPr>
+                <a:solidFill>
+                  <a:schemeClr val="tx2"/>
+                </a:solidFill>
+              </a:defRPr>
+            </a:lvl4pPr>
+            <a:lvl5pPr eaLnBrk="1" hangingPunct="1">
+              <a:defRPr>
+                <a:solidFill>
+                  <a:schemeClr val="tx2"/>
+                </a:solidFill>
+              </a:defRPr>
+            </a:lvl5pPr>
+            <a:lvl6pPr eaLnBrk="1" hangingPunct="1">
+              <a:defRPr>
+                <a:solidFill>
+                  <a:schemeClr val="tx2"/>
+                </a:solidFill>
+              </a:defRPr>
+            </a:lvl6pPr>
+            <a:lvl7pPr eaLnBrk="1" hangingPunct="1">
+              <a:defRPr>
+                <a:solidFill>
+                  <a:schemeClr val="tx2"/>
+                </a:solidFill>
+              </a:defRPr>
+            </a:lvl7pPr>
+            <a:lvl8pPr eaLnBrk="1" hangingPunct="1">
+              <a:defRPr>
+                <a:solidFill>
+                  <a:schemeClr val="tx2"/>
+                </a:solidFill>
+              </a:defRPr>
+            </a:lvl8pPr>
+            <a:lvl9pPr eaLnBrk="1" hangingPunct="1">
+              <a:defRPr>
+                <a:solidFill>
+                  <a:schemeClr val="tx2"/>
+                </a:solidFill>
+              </a:defRPr>
+            </a:lvl9pPr>
+          </a:lstStyle>
+          <a:p>
+            <a:r>
+              <a:rPr lang="en-US" dirty="0"/>
+              <a:t>USP</a:t>
+            </a:r>
+          </a:p>
+        </p:txBody>
+      </p:sp>
+      <p:sp>
+        <p:nvSpPr>
+          <p:cNvPr id="8" name="Text Placeholder 2">
+            <a:extLst>
+              <a:ext uri="{FF2B5EF4-FFF2-40B4-BE49-F238E27FC236}">
+                <a16:creationId xmlns:a16="http://schemas.microsoft.com/office/drawing/2014/main" id="{85F3326E-0A51-92FD-E1C6-F7C309A2406B}"/>
+              </a:ext>
+            </a:extLst>
+          </p:cNvPr>
+          <p:cNvSpPr txBox="1">
+            <a:spLocks/>
+          </p:cNvSpPr>
+          <p:nvPr/>
+        </p:nvSpPr>
+        <p:spPr>
+          <a:xfrm>
+            <a:off x="746760" y="2441589"/>
+            <a:ext cx="3358073" cy="3709987"/>
+          </a:xfrm>
+          <a:prstGeom prst="rect">
+            <a:avLst/>
+          </a:prstGeom>
+        </p:spPr>
+        <p:txBody>
+          <a:bodyPr vert="horz" lIns="0" tIns="457200" rIns="0" bIns="0" rtlCol="0">
+            <a:normAutofit fontScale="92500" lnSpcReduction="20000"/>
+          </a:bodyPr>
+          <a:lstStyle>
+            <a:lvl1pPr marL="283464" indent="-283464" algn="l" defTabSz="914400" rtl="0" eaLnBrk="1" latinLnBrk="0" hangingPunct="1">
+              <a:lnSpc>
+                <a:spcPct val="80000"/>
+              </a:lnSpc>
+              <a:spcBef>
+                <a:spcPts val="2200"/>
+              </a:spcBef>
+              <a:buFont typeface="Arial" panose="020B0604020202020204" pitchFamily="34" charset="0"/>
+              <a:buChar char="•"/>
+              <a:defRPr lang="en-US" sz="2400" b="1" i="0" kern="1200" dirty="0">
+                <a:solidFill>
+                  <a:schemeClr val="tx2">
+                    <a:lumMod val="75000"/>
+                  </a:schemeClr>
+                </a:solidFill>
+                <a:latin typeface="+mn-lt"/>
+                <a:ea typeface="+mn-ea"/>
+                <a:cs typeface="+mn-cs"/>
+              </a:defRPr>
+            </a:lvl1pPr>
+            <a:lvl2pPr marL="685800" indent="-283464" algn="l" defTabSz="914400" rtl="0" eaLnBrk="1" latinLnBrk="0" hangingPunct="1">
+              <a:lnSpc>
+                <a:spcPct val="90000"/>
+              </a:lnSpc>
+              <a:spcBef>
+                <a:spcPts val="600"/>
+              </a:spcBef>
+              <a:buFont typeface="Arial" panose="020B0604020202020204" pitchFamily="34" charset="0"/>
+              <a:buChar char="•"/>
+              <a:defRPr sz="2000" b="0" i="0" kern="1200">
+                <a:solidFill>
+                  <a:schemeClr val="bg1"/>
+                </a:solidFill>
+                <a:latin typeface="+mn-lt"/>
+                <a:ea typeface="+mn-ea"/>
+                <a:cs typeface="+mn-cs"/>
+              </a:defRPr>
+            </a:lvl2pPr>
+            <a:lvl3pPr marL="1143000" indent="-283464" algn="l" defTabSz="914400" rtl="0" eaLnBrk="1" latinLnBrk="0" hangingPunct="1">
+              <a:lnSpc>
+                <a:spcPct val="90000"/>
+              </a:lnSpc>
+              <a:spcBef>
+                <a:spcPts val="1800"/>
+              </a:spcBef>
+              <a:buFont typeface="Arial" panose="020B0604020202020204" pitchFamily="34" charset="0"/>
+              <a:buChar char="•"/>
+              <a:defRPr sz="2000" b="0" i="0" kern="1200">
+                <a:solidFill>
+                  <a:schemeClr val="bg1"/>
+                </a:solidFill>
+                <a:latin typeface="+mn-lt"/>
+                <a:ea typeface="+mn-ea"/>
+                <a:cs typeface="+mn-cs"/>
+              </a:defRPr>
+            </a:lvl3pPr>
+            <a:lvl4pPr marL="1600200" indent="-283464" algn="l" defTabSz="914400" rtl="0" eaLnBrk="1" latinLnBrk="0" hangingPunct="1">
+              <a:lnSpc>
+                <a:spcPct val="90000"/>
+              </a:lnSpc>
+              <a:spcBef>
+                <a:spcPts val="1800"/>
+              </a:spcBef>
+              <a:buFont typeface="Arial" panose="020B0604020202020204" pitchFamily="34" charset="0"/>
+              <a:buChar char="•"/>
+              <a:defRPr sz="2000" b="0" i="0" kern="1200">
+                <a:solidFill>
+                  <a:schemeClr val="bg1"/>
+                </a:solidFill>
+                <a:latin typeface="+mn-lt"/>
+                <a:ea typeface="+mn-ea"/>
+                <a:cs typeface="+mn-cs"/>
+              </a:defRPr>
+            </a:lvl4pPr>
+            <a:lvl5pPr marL="2057400" indent="-283464" algn="l" defTabSz="914400" rtl="0" eaLnBrk="1" latinLnBrk="0" hangingPunct="1">
+              <a:lnSpc>
+                <a:spcPct val="90000"/>
+              </a:lnSpc>
+              <a:spcBef>
+                <a:spcPts val="1800"/>
+              </a:spcBef>
+              <a:buFont typeface="Arial" panose="020B0604020202020204" pitchFamily="34" charset="0"/>
+              <a:buChar char="•"/>
+              <a:defRPr sz="2000" b="0" i="0" kern="1200">
+                <a:solidFill>
+                  <a:schemeClr val="bg1"/>
+                </a:solidFill>
+                <a:latin typeface="+mn-lt"/>
+                <a:ea typeface="+mn-ea"/>
+                <a:cs typeface="+mn-cs"/>
+              </a:defRPr>
+            </a:lvl5pPr>
+            <a:lvl6pPr marL="2514600" indent="-228600" algn="l" defTabSz="914400" rtl="0" eaLnBrk="1" latinLnBrk="0" hangingPunct="1">
+              <a:lnSpc>
+                <a:spcPct val="90000"/>
+              </a:lnSpc>
+              <a:spcBef>
+                <a:spcPts val="500"/>
+              </a:spcBef>
+              <a:buFont typeface="Arial" panose="020B0604020202020204" pitchFamily="34" charset="0"/>
+              <a:buChar char="•"/>
+              <a:defRPr sz="1800" kern="1200">
+                <a:solidFill>
+                  <a:schemeClr val="tx1"/>
+                </a:solidFill>
+                <a:latin typeface="+mn-lt"/>
+                <a:ea typeface="+mn-ea"/>
+                <a:cs typeface="+mn-cs"/>
+              </a:defRPr>
+            </a:lvl6pPr>
+            <a:lvl7pPr marL="2971800" indent="-228600" algn="l" defTabSz="914400" rtl="0" eaLnBrk="1" latinLnBrk="0" hangingPunct="1">
+              <a:lnSpc>
+                <a:spcPct val="90000"/>
+              </a:lnSpc>
+              <a:spcBef>
+                <a:spcPts val="500"/>
+              </a:spcBef>
+              <a:buFont typeface="Arial" panose="020B0604020202020204" pitchFamily="34" charset="0"/>
+              <a:buChar char="•"/>
+              <a:defRPr sz="1800" kern="1200">
+                <a:solidFill>
+                  <a:schemeClr val="tx1"/>
+                </a:solidFill>
+                <a:latin typeface="+mn-lt"/>
+                <a:ea typeface="+mn-ea"/>
+                <a:cs typeface="+mn-cs"/>
+              </a:defRPr>
+            </a:lvl7pPr>
+            <a:lvl8pPr marL="3429000" indent="-228600" algn="l" defTabSz="914400" rtl="0" eaLnBrk="1" latinLnBrk="0" hangingPunct="1">
+              <a:lnSpc>
+                <a:spcPct val="90000"/>
+              </a:lnSpc>
+              <a:spcBef>
+                <a:spcPts val="500"/>
+              </a:spcBef>
+              <a:buFont typeface="Arial" panose="020B0604020202020204" pitchFamily="34" charset="0"/>
+              <a:buChar char="•"/>
+              <a:defRPr sz="1800" kern="1200">
+                <a:solidFill>
+                  <a:schemeClr val="tx1"/>
+                </a:solidFill>
+                <a:latin typeface="+mn-lt"/>
+                <a:ea typeface="+mn-ea"/>
+                <a:cs typeface="+mn-cs"/>
+              </a:defRPr>
+            </a:lvl8pPr>
+            <a:lvl9pPr marL="3886200" indent="-228600" algn="l" defTabSz="914400" rtl="0" eaLnBrk="1" latinLnBrk="0" hangingPunct="1">
+              <a:lnSpc>
+                <a:spcPct val="90000"/>
+              </a:lnSpc>
+              <a:spcBef>
+                <a:spcPts val="500"/>
+              </a:spcBef>
+              <a:buFont typeface="Arial" panose="020B0604020202020204" pitchFamily="34" charset="0"/>
+              <a:buChar char="•"/>
+              <a:defRPr sz="1800" kern="1200">
+                <a:solidFill>
+                  <a:schemeClr val="tx1"/>
+                </a:solidFill>
+                <a:latin typeface="+mn-lt"/>
+                <a:ea typeface="+mn-ea"/>
+                <a:cs typeface="+mn-cs"/>
+              </a:defRPr>
+            </a:lvl9pPr>
+          </a:lstStyle>
+          <a:p>
+            <a:r>
+              <a:rPr lang="en-US" dirty="0"/>
+              <a:t>Frontend</a:t>
+            </a:r>
+          </a:p>
+          <a:p>
+            <a:pPr lvl="1"/>
+            <a:r>
+              <a:rPr lang="en-US" dirty="0"/>
+              <a:t>React.js</a:t>
+            </a:r>
+          </a:p>
+          <a:p>
+            <a:pPr lvl="1"/>
+            <a:r>
+              <a:rPr lang="en-US" dirty="0"/>
+              <a:t>Tailwind CSS</a:t>
+            </a:r>
+          </a:p>
+          <a:p>
+            <a:pPr lvl="1"/>
+            <a:r>
+              <a:rPr lang="en-US" dirty="0"/>
+              <a:t>Axios</a:t>
+            </a:r>
+          </a:p>
+          <a:p>
+            <a:r>
+              <a:rPr lang="en-US" dirty="0"/>
+              <a:t>Backend</a:t>
+            </a:r>
+          </a:p>
+          <a:p>
+            <a:pPr lvl="1"/>
+            <a:r>
+              <a:rPr lang="en-US" dirty="0"/>
+              <a:t>Node.js</a:t>
+            </a:r>
+          </a:p>
+          <a:p>
+            <a:pPr lvl="1"/>
+            <a:r>
+              <a:rPr lang="en-US" dirty="0"/>
+              <a:t>Express</a:t>
+            </a:r>
+          </a:p>
+          <a:p>
+            <a:pPr lvl="1"/>
+            <a:r>
+              <a:rPr lang="en-US" dirty="0"/>
+              <a:t>JWT Authentication</a:t>
+            </a:r>
+          </a:p>
+          <a:p>
             <a:r>
               <a:rPr lang="en-US" dirty="0"/>
               <a:t>Database</a:t>
@@ -9976,6 +10633,20 @@
               <a:rPr lang="en-US" dirty="0"/>
               <a:t>MongoDB</a:t>
             </a:r>
+          </a:p>
+          <a:p>
+            <a:pPr marL="0" indent="0">
+              <a:buFont typeface="Arial" panose="020B0604020202020204" pitchFamily="34" charset="0"/>
+              <a:buNone/>
+            </a:pPr>
+            <a:endParaRPr lang="en-US" dirty="0"/>
+          </a:p>
+          <a:p>
+            <a:pPr marL="402336" lvl="1" indent="0">
+              <a:buFont typeface="Arial" panose="020B0604020202020204" pitchFamily="34" charset="0"/>
+              <a:buNone/>
+            </a:pPr>
+            <a:endParaRPr lang="en-US" dirty="0"/>
           </a:p>
           <a:p>
             <a:pPr marL="0" indent="0">
@@ -10564,7 +11235,7 @@
           <a:p>
             <a:r>
               <a:rPr lang="en-US" dirty="0"/>
-              <a:t>Dashboard</a:t>
+              <a:t>Sign In</a:t>
             </a:r>
           </a:p>
         </p:txBody>
@@ -10631,10 +11302,10 @@
       </p:sp>
       <p:pic>
         <p:nvPicPr>
-          <p:cNvPr id="6" name="Picture 5">
+          <p:cNvPr id="9" name="Picture 8">
             <a:extLst>
               <a:ext uri="{FF2B5EF4-FFF2-40B4-BE49-F238E27FC236}">
-                <a16:creationId xmlns:a16="http://schemas.microsoft.com/office/drawing/2014/main" id="{3BE2E137-79CE-E6A8-FC46-0F483B0E8E76}"/>
+                <a16:creationId xmlns:a16="http://schemas.microsoft.com/office/drawing/2014/main" id="{46E39607-5928-A5D1-9FE8-D56D52B5FF90}"/>
               </a:ext>
             </a:extLst>
           </p:cNvPr>
@@ -10651,8 +11322,8 @@
         </p:blipFill>
         <p:spPr>
           <a:xfrm>
-            <a:off x="1375576" y="1422867"/>
-            <a:ext cx="8658970" cy="4878546"/>
+            <a:off x="1496373" y="1332302"/>
+            <a:ext cx="8771049" cy="4941693"/>
           </a:xfrm>
           <a:prstGeom prst="rect">
             <a:avLst/>
@@ -10673,6 +11344,324 @@
 </file>
 
 <file path=ppt/slides/slide5.xml><?xml version="1.0" encoding="utf-8"?>
+<p:sld xmlns:a="http://schemas.openxmlformats.org/drawingml/2006/main" xmlns:r="http://schemas.openxmlformats.org/officeDocument/2006/relationships" xmlns:p="http://schemas.openxmlformats.org/presentationml/2006/main">
+  <p:cSld>
+    <p:spTree>
+      <p:nvGrpSpPr>
+        <p:cNvPr id="1" name="">
+          <a:extLst>
+            <a:ext uri="{FF2B5EF4-FFF2-40B4-BE49-F238E27FC236}">
+              <a16:creationId xmlns:a16="http://schemas.microsoft.com/office/drawing/2014/main" id="{A01B701E-A4EA-AA38-7F77-6D4A4139A02E}"/>
+            </a:ext>
+          </a:extLst>
+        </p:cNvPr>
+        <p:cNvGrpSpPr/>
+        <p:nvPr/>
+      </p:nvGrpSpPr>
+      <p:grpSpPr>
+        <a:xfrm>
+          <a:off x="0" y="0"/>
+          <a:ext cx="0" cy="0"/>
+          <a:chOff x="0" y="0"/>
+          <a:chExt cx="0" cy="0"/>
+        </a:xfrm>
+      </p:grpSpPr>
+      <p:sp>
+        <p:nvSpPr>
+          <p:cNvPr id="2" name="Title 1">
+            <a:extLst>
+              <a:ext uri="{FF2B5EF4-FFF2-40B4-BE49-F238E27FC236}">
+                <a16:creationId xmlns:a16="http://schemas.microsoft.com/office/drawing/2014/main" id="{EEC7C361-F0E4-C2C6-C28C-68D23D5032C1}"/>
+              </a:ext>
+            </a:extLst>
+          </p:cNvPr>
+          <p:cNvSpPr>
+            <a:spLocks noGrp="1"/>
+          </p:cNvSpPr>
+          <p:nvPr>
+            <p:ph type="title"/>
+          </p:nvPr>
+        </p:nvSpPr>
+        <p:spPr>
+          <a:xfrm>
+            <a:off x="594360" y="-310267"/>
+            <a:ext cx="9778365" cy="1494596"/>
+          </a:xfrm>
+        </p:spPr>
+        <p:txBody>
+          <a:bodyPr/>
+          <a:lstStyle/>
+          <a:p>
+            <a:r>
+              <a:rPr lang="en-US" dirty="0"/>
+              <a:t>Dashboard</a:t>
+            </a:r>
+          </a:p>
+        </p:txBody>
+      </p:sp>
+      <p:sp>
+        <p:nvSpPr>
+          <p:cNvPr id="3" name="Content Placeholder 2">
+            <a:extLst>
+              <a:ext uri="{FF2B5EF4-FFF2-40B4-BE49-F238E27FC236}">
+                <a16:creationId xmlns:a16="http://schemas.microsoft.com/office/drawing/2014/main" id="{47E6BA7D-B34D-CE4D-2229-1136902E414F}"/>
+              </a:ext>
+            </a:extLst>
+          </p:cNvPr>
+          <p:cNvSpPr>
+            <a:spLocks noGrp="1"/>
+          </p:cNvSpPr>
+          <p:nvPr>
+            <p:ph sz="quarter" idx="15"/>
+          </p:nvPr>
+        </p:nvSpPr>
+        <p:spPr>
+          <a:xfrm>
+            <a:off x="594360" y="2676525"/>
+            <a:ext cx="4490827" cy="3597470"/>
+          </a:xfrm>
+        </p:spPr>
+        <p:txBody>
+          <a:bodyPr/>
+          <a:lstStyle/>
+          <a:p>
+            <a:endParaRPr lang="en-US" dirty="0"/>
+          </a:p>
+        </p:txBody>
+      </p:sp>
+      <p:sp>
+        <p:nvSpPr>
+          <p:cNvPr id="4" name="Content Placeholder 3">
+            <a:extLst>
+              <a:ext uri="{FF2B5EF4-FFF2-40B4-BE49-F238E27FC236}">
+                <a16:creationId xmlns:a16="http://schemas.microsoft.com/office/drawing/2014/main" id="{CE6AF753-2BB5-3987-4E71-28E5AD4FEB5D}"/>
+              </a:ext>
+            </a:extLst>
+          </p:cNvPr>
+          <p:cNvSpPr>
+            <a:spLocks noGrp="1"/>
+          </p:cNvSpPr>
+          <p:nvPr>
+            <p:ph sz="quarter" idx="16"/>
+          </p:nvPr>
+        </p:nvSpPr>
+        <p:spPr>
+          <a:xfrm>
+            <a:off x="5881898" y="2676525"/>
+            <a:ext cx="4490827" cy="3597470"/>
+          </a:xfrm>
+        </p:spPr>
+        <p:txBody>
+          <a:bodyPr/>
+          <a:lstStyle/>
+          <a:p>
+            <a:endParaRPr lang="en-US" dirty="0"/>
+          </a:p>
+        </p:txBody>
+      </p:sp>
+      <p:pic>
+        <p:nvPicPr>
+          <p:cNvPr id="7" name="Picture 6">
+            <a:extLst>
+              <a:ext uri="{FF2B5EF4-FFF2-40B4-BE49-F238E27FC236}">
+                <a16:creationId xmlns:a16="http://schemas.microsoft.com/office/drawing/2014/main" id="{12EDE240-DDF1-C55F-81EF-0E51BD0CA9D9}"/>
+              </a:ext>
+            </a:extLst>
+          </p:cNvPr>
+          <p:cNvPicPr>
+            <a:picLocks noChangeAspect="1"/>
+          </p:cNvPicPr>
+          <p:nvPr/>
+        </p:nvPicPr>
+        <p:blipFill>
+          <a:blip r:embed="rId3"/>
+          <a:stretch>
+            <a:fillRect/>
+          </a:stretch>
+        </p:blipFill>
+        <p:spPr>
+          <a:xfrm>
+            <a:off x="1311964" y="1184329"/>
+            <a:ext cx="9351495" cy="5268721"/>
+          </a:xfrm>
+          <a:prstGeom prst="rect">
+            <a:avLst/>
+          </a:prstGeom>
+        </p:spPr>
+      </p:pic>
+    </p:spTree>
+    <p:extLst>
+      <p:ext uri="{BB962C8B-B14F-4D97-AF65-F5344CB8AC3E}">
+        <p14:creationId xmlns:p14="http://schemas.microsoft.com/office/powerpoint/2010/main" val="3081664264"/>
+      </p:ext>
+    </p:extLst>
+  </p:cSld>
+  <p:clrMapOvr>
+    <a:masterClrMapping/>
+  </p:clrMapOvr>
+</p:sld>
+</file>
+
+<file path=ppt/slides/slide6.xml><?xml version="1.0" encoding="utf-8"?>
+<p:sld xmlns:a="http://schemas.openxmlformats.org/drawingml/2006/main" xmlns:r="http://schemas.openxmlformats.org/officeDocument/2006/relationships" xmlns:p="http://schemas.openxmlformats.org/presentationml/2006/main">
+  <p:cSld>
+    <p:spTree>
+      <p:nvGrpSpPr>
+        <p:cNvPr id="1" name="">
+          <a:extLst>
+            <a:ext uri="{FF2B5EF4-FFF2-40B4-BE49-F238E27FC236}">
+              <a16:creationId xmlns:a16="http://schemas.microsoft.com/office/drawing/2014/main" id="{C9E4FE7D-436A-F157-D0C9-CDE32DC35665}"/>
+            </a:ext>
+          </a:extLst>
+        </p:cNvPr>
+        <p:cNvGrpSpPr/>
+        <p:nvPr/>
+      </p:nvGrpSpPr>
+      <p:grpSpPr>
+        <a:xfrm>
+          <a:off x="0" y="0"/>
+          <a:ext cx="0" cy="0"/>
+          <a:chOff x="0" y="0"/>
+          <a:chExt cx="0" cy="0"/>
+        </a:xfrm>
+      </p:grpSpPr>
+      <p:sp>
+        <p:nvSpPr>
+          <p:cNvPr id="2" name="Title 1">
+            <a:extLst>
+              <a:ext uri="{FF2B5EF4-FFF2-40B4-BE49-F238E27FC236}">
+                <a16:creationId xmlns:a16="http://schemas.microsoft.com/office/drawing/2014/main" id="{0E8D7E33-9E58-7909-DEA3-9F248228847E}"/>
+              </a:ext>
+            </a:extLst>
+          </p:cNvPr>
+          <p:cNvSpPr>
+            <a:spLocks noGrp="1"/>
+          </p:cNvSpPr>
+          <p:nvPr>
+            <p:ph type="title"/>
+          </p:nvPr>
+        </p:nvSpPr>
+        <p:spPr>
+          <a:xfrm>
+            <a:off x="594360" y="-310267"/>
+            <a:ext cx="9778365" cy="1494596"/>
+          </a:xfrm>
+        </p:spPr>
+        <p:txBody>
+          <a:bodyPr/>
+          <a:lstStyle/>
+          <a:p>
+            <a:r>
+              <a:rPr lang="en-US" dirty="0"/>
+              <a:t>Dashboard</a:t>
+            </a:r>
+          </a:p>
+        </p:txBody>
+      </p:sp>
+      <p:sp>
+        <p:nvSpPr>
+          <p:cNvPr id="3" name="Content Placeholder 2">
+            <a:extLst>
+              <a:ext uri="{FF2B5EF4-FFF2-40B4-BE49-F238E27FC236}">
+                <a16:creationId xmlns:a16="http://schemas.microsoft.com/office/drawing/2014/main" id="{2FD8DC8B-E658-9E98-D3A8-889CD26E6C36}"/>
+              </a:ext>
+            </a:extLst>
+          </p:cNvPr>
+          <p:cNvSpPr>
+            <a:spLocks noGrp="1"/>
+          </p:cNvSpPr>
+          <p:nvPr>
+            <p:ph sz="quarter" idx="15"/>
+          </p:nvPr>
+        </p:nvSpPr>
+        <p:spPr>
+          <a:xfrm>
+            <a:off x="594360" y="2676525"/>
+            <a:ext cx="4490827" cy="3597470"/>
+          </a:xfrm>
+        </p:spPr>
+        <p:txBody>
+          <a:bodyPr/>
+          <a:lstStyle/>
+          <a:p>
+            <a:endParaRPr lang="en-US" dirty="0"/>
+          </a:p>
+        </p:txBody>
+      </p:sp>
+      <p:sp>
+        <p:nvSpPr>
+          <p:cNvPr id="4" name="Content Placeholder 3">
+            <a:extLst>
+              <a:ext uri="{FF2B5EF4-FFF2-40B4-BE49-F238E27FC236}">
+                <a16:creationId xmlns:a16="http://schemas.microsoft.com/office/drawing/2014/main" id="{E2E150AB-45E8-A7AD-AF80-A826FF6E9775}"/>
+              </a:ext>
+            </a:extLst>
+          </p:cNvPr>
+          <p:cNvSpPr>
+            <a:spLocks noGrp="1"/>
+          </p:cNvSpPr>
+          <p:nvPr>
+            <p:ph sz="quarter" idx="16"/>
+          </p:nvPr>
+        </p:nvSpPr>
+        <p:spPr>
+          <a:xfrm>
+            <a:off x="5881898" y="2676525"/>
+            <a:ext cx="4490827" cy="3597470"/>
+          </a:xfrm>
+        </p:spPr>
+        <p:txBody>
+          <a:bodyPr/>
+          <a:lstStyle/>
+          <a:p>
+            <a:endParaRPr lang="en-US" dirty="0"/>
+          </a:p>
+        </p:txBody>
+      </p:sp>
+      <p:pic>
+        <p:nvPicPr>
+          <p:cNvPr id="6" name="Picture 5">
+            <a:extLst>
+              <a:ext uri="{FF2B5EF4-FFF2-40B4-BE49-F238E27FC236}">
+                <a16:creationId xmlns:a16="http://schemas.microsoft.com/office/drawing/2014/main" id="{1A01EC49-EB23-D2E4-AC9F-E66BD0E1FA5B}"/>
+              </a:ext>
+            </a:extLst>
+          </p:cNvPr>
+          <p:cNvPicPr>
+            <a:picLocks noChangeAspect="1"/>
+          </p:cNvPicPr>
+          <p:nvPr/>
+        </p:nvPicPr>
+        <p:blipFill>
+          <a:blip r:embed="rId3"/>
+          <a:stretch>
+            <a:fillRect/>
+          </a:stretch>
+        </p:blipFill>
+        <p:spPr>
+          <a:xfrm>
+            <a:off x="1265785" y="1184329"/>
+            <a:ext cx="9232225" cy="5201524"/>
+          </a:xfrm>
+          <a:prstGeom prst="rect">
+            <a:avLst/>
+          </a:prstGeom>
+        </p:spPr>
+      </p:pic>
+    </p:spTree>
+    <p:extLst>
+      <p:ext uri="{BB962C8B-B14F-4D97-AF65-F5344CB8AC3E}">
+        <p14:creationId xmlns:p14="http://schemas.microsoft.com/office/powerpoint/2010/main" val="2940611994"/>
+      </p:ext>
+    </p:extLst>
+  </p:cSld>
+  <p:clrMapOvr>
+    <a:masterClrMapping/>
+  </p:clrMapOvr>
+</p:sld>
+</file>
+
+<file path=ppt/slides/slide7.xml><?xml version="1.0" encoding="utf-8"?>
 <p:sld xmlns:a="http://schemas.openxmlformats.org/drawingml/2006/main" xmlns:r="http://schemas.openxmlformats.org/officeDocument/2006/relationships" xmlns:p="http://schemas.openxmlformats.org/presentationml/2006/main">
   <p:cSld>
     <p:spTree>
@@ -10831,7 +11820,166 @@
 </p:sld>
 </file>
 
-<file path=ppt/slides/slide6.xml><?xml version="1.0" encoding="utf-8"?>
+<file path=ppt/slides/slide8.xml><?xml version="1.0" encoding="utf-8"?>
+<p:sld xmlns:a="http://schemas.openxmlformats.org/drawingml/2006/main" xmlns:r="http://schemas.openxmlformats.org/officeDocument/2006/relationships" xmlns:p="http://schemas.openxmlformats.org/presentationml/2006/main">
+  <p:cSld>
+    <p:spTree>
+      <p:nvGrpSpPr>
+        <p:cNvPr id="1" name="">
+          <a:extLst>
+            <a:ext uri="{FF2B5EF4-FFF2-40B4-BE49-F238E27FC236}">
+              <a16:creationId xmlns:a16="http://schemas.microsoft.com/office/drawing/2014/main" id="{324C96A0-DB6F-6CA0-8A21-39900AF6DC67}"/>
+            </a:ext>
+          </a:extLst>
+        </p:cNvPr>
+        <p:cNvGrpSpPr/>
+        <p:nvPr/>
+      </p:nvGrpSpPr>
+      <p:grpSpPr>
+        <a:xfrm>
+          <a:off x="0" y="0"/>
+          <a:ext cx="0" cy="0"/>
+          <a:chOff x="0" y="0"/>
+          <a:chExt cx="0" cy="0"/>
+        </a:xfrm>
+      </p:grpSpPr>
+      <p:sp>
+        <p:nvSpPr>
+          <p:cNvPr id="2" name="Title 1">
+            <a:extLst>
+              <a:ext uri="{FF2B5EF4-FFF2-40B4-BE49-F238E27FC236}">
+                <a16:creationId xmlns:a16="http://schemas.microsoft.com/office/drawing/2014/main" id="{3A32469C-DA2D-1C75-BA28-A0AB77469E1B}"/>
+              </a:ext>
+            </a:extLst>
+          </p:cNvPr>
+          <p:cNvSpPr>
+            <a:spLocks noGrp="1"/>
+          </p:cNvSpPr>
+          <p:nvPr>
+            <p:ph type="title"/>
+          </p:nvPr>
+        </p:nvSpPr>
+        <p:spPr>
+          <a:xfrm>
+            <a:off x="594360" y="-310267"/>
+            <a:ext cx="9778365" cy="1494596"/>
+          </a:xfrm>
+        </p:spPr>
+        <p:txBody>
+          <a:bodyPr/>
+          <a:lstStyle/>
+          <a:p>
+            <a:r>
+              <a:rPr lang="en-US" dirty="0"/>
+              <a:t>Bookings Page</a:t>
+            </a:r>
+          </a:p>
+        </p:txBody>
+      </p:sp>
+      <p:sp>
+        <p:nvSpPr>
+          <p:cNvPr id="3" name="Content Placeholder 2">
+            <a:extLst>
+              <a:ext uri="{FF2B5EF4-FFF2-40B4-BE49-F238E27FC236}">
+                <a16:creationId xmlns:a16="http://schemas.microsoft.com/office/drawing/2014/main" id="{39DFC348-15A0-AB2C-2E43-E61D9F86515A}"/>
+              </a:ext>
+            </a:extLst>
+          </p:cNvPr>
+          <p:cNvSpPr>
+            <a:spLocks noGrp="1"/>
+          </p:cNvSpPr>
+          <p:nvPr>
+            <p:ph sz="quarter" idx="15"/>
+          </p:nvPr>
+        </p:nvSpPr>
+        <p:spPr>
+          <a:xfrm>
+            <a:off x="594360" y="2676525"/>
+            <a:ext cx="4490827" cy="3597470"/>
+          </a:xfrm>
+        </p:spPr>
+        <p:txBody>
+          <a:bodyPr/>
+          <a:lstStyle/>
+          <a:p>
+            <a:endParaRPr lang="en-US" dirty="0"/>
+          </a:p>
+        </p:txBody>
+      </p:sp>
+      <p:sp>
+        <p:nvSpPr>
+          <p:cNvPr id="4" name="Content Placeholder 3">
+            <a:extLst>
+              <a:ext uri="{FF2B5EF4-FFF2-40B4-BE49-F238E27FC236}">
+                <a16:creationId xmlns:a16="http://schemas.microsoft.com/office/drawing/2014/main" id="{1D620882-C8FE-AEA4-79AC-89BE922D169F}"/>
+              </a:ext>
+            </a:extLst>
+          </p:cNvPr>
+          <p:cNvSpPr>
+            <a:spLocks noGrp="1"/>
+          </p:cNvSpPr>
+          <p:nvPr>
+            <p:ph sz="quarter" idx="16"/>
+          </p:nvPr>
+        </p:nvSpPr>
+        <p:spPr>
+          <a:xfrm>
+            <a:off x="5881898" y="2676525"/>
+            <a:ext cx="4490827" cy="3597470"/>
+          </a:xfrm>
+        </p:spPr>
+        <p:txBody>
+          <a:bodyPr/>
+          <a:lstStyle/>
+          <a:p>
+            <a:endParaRPr lang="en-US" dirty="0"/>
+          </a:p>
+        </p:txBody>
+      </p:sp>
+      <p:pic>
+        <p:nvPicPr>
+          <p:cNvPr id="6" name="Picture 5">
+            <a:extLst>
+              <a:ext uri="{FF2B5EF4-FFF2-40B4-BE49-F238E27FC236}">
+                <a16:creationId xmlns:a16="http://schemas.microsoft.com/office/drawing/2014/main" id="{187663CD-B054-ABC2-AA7C-76E748DC830B}"/>
+              </a:ext>
+            </a:extLst>
+          </p:cNvPr>
+          <p:cNvPicPr>
+            <a:picLocks noChangeAspect="1"/>
+          </p:cNvPicPr>
+          <p:nvPr/>
+        </p:nvPicPr>
+        <p:blipFill>
+          <a:blip r:embed="rId3"/>
+          <a:stretch>
+            <a:fillRect/>
+          </a:stretch>
+        </p:blipFill>
+        <p:spPr>
+          <a:xfrm>
+            <a:off x="1313494" y="1241108"/>
+            <a:ext cx="9136808" cy="5147764"/>
+          </a:xfrm>
+          <a:prstGeom prst="rect">
+            <a:avLst/>
+          </a:prstGeom>
+        </p:spPr>
+      </p:pic>
+    </p:spTree>
+    <p:extLst>
+      <p:ext uri="{BB962C8B-B14F-4D97-AF65-F5344CB8AC3E}">
+        <p14:creationId xmlns:p14="http://schemas.microsoft.com/office/powerpoint/2010/main" val="4075293358"/>
+      </p:ext>
+    </p:extLst>
+  </p:cSld>
+  <p:clrMapOvr>
+    <a:masterClrMapping/>
+  </p:clrMapOvr>
+</p:sld>
+</file>
+
+<file path=ppt/slides/slide9.xml><?xml version="1.0" encoding="utf-8"?>
 <p:sld xmlns:a="http://schemas.openxmlformats.org/drawingml/2006/main" xmlns:r="http://schemas.openxmlformats.org/officeDocument/2006/relationships" xmlns:p="http://schemas.openxmlformats.org/presentationml/2006/main">
   <p:cSld>
     <p:spTree>
@@ -11732,12 +12880,23 @@
 </file>
 
 <file path=customXml/item1.xml><?xml version="1.0" encoding="utf-8"?>
-<?mso-contentType ?>
-<FormTemplates xmlns="http://schemas.microsoft.com/sharepoint/v3/contenttype/forms">
-  <Display>DocumentLibraryForm</Display>
-  <Edit>DocumentLibraryForm</Edit>
-  <New>DocumentLibraryForm</New>
-</FormTemplates>
+<p:properties xmlns:p="http://schemas.microsoft.com/office/2006/metadata/properties" xmlns:xsi="http://www.w3.org/2001/XMLSchema-instance" xmlns:pc="http://schemas.microsoft.com/office/infopath/2007/PartnerControls">
+  <documentManagement>
+    <Background xmlns="71af3243-3dd4-4a8d-8c0d-dd76da1f02a5">false</Background>
+    <Status xmlns="71af3243-3dd4-4a8d-8c0d-dd76da1f02a5">Not started</Status>
+    <_ip_UnifiedCompliancePolicyUIAction xmlns="http://schemas.microsoft.com/sharepoint/v3" xsi:nil="true"/>
+    <Image xmlns="71af3243-3dd4-4a8d-8c0d-dd76da1f02a5">
+      <Url xsi:nil="true"/>
+      <Description xsi:nil="true"/>
+    </Image>
+    <_ip_UnifiedCompliancePolicyProperties xmlns="http://schemas.microsoft.com/sharepoint/v3" xsi:nil="true"/>
+    <ImageTagsTaxHTField xmlns="71af3243-3dd4-4a8d-8c0d-dd76da1f02a5">
+      <Terms xmlns="http://schemas.microsoft.com/office/infopath/2007/PartnerControls"/>
+    </ImageTagsTaxHTField>
+    <TaxCatchAll xmlns="230e9df3-be65-4c73-a93b-d1236ebd677e" xsi:nil="true"/>
+    <MediaServiceKeyPoints xmlns="71af3243-3dd4-4a8d-8c0d-dd76da1f02a5" xsi:nil="true"/>
+  </documentManagement>
+</p:properties>
 </file>
 
 <file path=customXml/item2.xml><?xml version="1.0" encoding="utf-8"?>
@@ -12053,29 +13212,22 @@
 </file>
 
 <file path=customXml/item3.xml><?xml version="1.0" encoding="utf-8"?>
-<p:properties xmlns:p="http://schemas.microsoft.com/office/2006/metadata/properties" xmlns:xsi="http://www.w3.org/2001/XMLSchema-instance" xmlns:pc="http://schemas.microsoft.com/office/infopath/2007/PartnerControls">
-  <documentManagement>
-    <Background xmlns="71af3243-3dd4-4a8d-8c0d-dd76da1f02a5">false</Background>
-    <Status xmlns="71af3243-3dd4-4a8d-8c0d-dd76da1f02a5">Not started</Status>
-    <_ip_UnifiedCompliancePolicyUIAction xmlns="http://schemas.microsoft.com/sharepoint/v3" xsi:nil="true"/>
-    <Image xmlns="71af3243-3dd4-4a8d-8c0d-dd76da1f02a5">
-      <Url xsi:nil="true"/>
-      <Description xsi:nil="true"/>
-    </Image>
-    <_ip_UnifiedCompliancePolicyProperties xmlns="http://schemas.microsoft.com/sharepoint/v3" xsi:nil="true"/>
-    <ImageTagsTaxHTField xmlns="71af3243-3dd4-4a8d-8c0d-dd76da1f02a5">
-      <Terms xmlns="http://schemas.microsoft.com/office/infopath/2007/PartnerControls"/>
-    </ImageTagsTaxHTField>
-    <TaxCatchAll xmlns="230e9df3-be65-4c73-a93b-d1236ebd677e" xsi:nil="true"/>
-    <MediaServiceKeyPoints xmlns="71af3243-3dd4-4a8d-8c0d-dd76da1f02a5" xsi:nil="true"/>
-  </documentManagement>
-</p:properties>
+<?mso-contentType ?>
+<FormTemplates xmlns="http://schemas.microsoft.com/sharepoint/v3/contenttype/forms">
+  <Display>DocumentLibraryForm</Display>
+  <Edit>DocumentLibraryForm</Edit>
+  <New>DocumentLibraryForm</New>
+</FormTemplates>
 </file>
 
 <file path=customXml/itemProps1.xml><?xml version="1.0" encoding="utf-8"?>
-<ds:datastoreItem xmlns:ds="http://schemas.openxmlformats.org/officeDocument/2006/customXml" ds:itemID="{C21FFAC0-05A2-416A-B06C-C248395482CF}">
+<ds:datastoreItem xmlns:ds="http://schemas.openxmlformats.org/officeDocument/2006/customXml" ds:itemID="{4F4B194E-8B30-4377-8C59-ECFB902D2A26}">
   <ds:schemaRefs>
-    <ds:schemaRef ds:uri="http://schemas.microsoft.com/sharepoint/v3/contenttype/forms"/>
+    <ds:schemaRef ds:uri="http://schemas.microsoft.com/office/2006/metadata/properties"/>
+    <ds:schemaRef ds:uri="http://schemas.microsoft.com/office/infopath/2007/PartnerControls"/>
+    <ds:schemaRef ds:uri="71af3243-3dd4-4a8d-8c0d-dd76da1f02a5"/>
+    <ds:schemaRef ds:uri="http://schemas.microsoft.com/sharepoint/v3"/>
+    <ds:schemaRef ds:uri="230e9df3-be65-4c73-a93b-d1236ebd677e"/>
   </ds:schemaRefs>
 </ds:datastoreItem>
 </file>
@@ -12102,13 +13254,9 @@
 </file>
 
 <file path=customXml/itemProps3.xml><?xml version="1.0" encoding="utf-8"?>
-<ds:datastoreItem xmlns:ds="http://schemas.openxmlformats.org/officeDocument/2006/customXml" ds:itemID="{4F4B194E-8B30-4377-8C59-ECFB902D2A26}">
+<ds:datastoreItem xmlns:ds="http://schemas.openxmlformats.org/officeDocument/2006/customXml" ds:itemID="{C21FFAC0-05A2-416A-B06C-C248395482CF}">
   <ds:schemaRefs>
-    <ds:schemaRef ds:uri="http://schemas.microsoft.com/office/2006/metadata/properties"/>
-    <ds:schemaRef ds:uri="http://schemas.microsoft.com/office/infopath/2007/PartnerControls"/>
-    <ds:schemaRef ds:uri="71af3243-3dd4-4a8d-8c0d-dd76da1f02a5"/>
-    <ds:schemaRef ds:uri="http://schemas.microsoft.com/sharepoint/v3"/>
-    <ds:schemaRef ds:uri="230e9df3-be65-4c73-a93b-d1236ebd677e"/>
+    <ds:schemaRef ds:uri="http://schemas.microsoft.com/sharepoint/v3/contenttype/forms"/>
   </ds:schemaRefs>
 </ds:datastoreItem>
 </file>

</xml_diff>